<commit_message>
Add fixes to enforce size.
</commit_message>
<xml_diff>
--- a/config/base-template.pptx
+++ b/config/base-template.pptx
@@ -8471,8 +8471,8 @@
         </p:blipFill>
         <p:spPr>
           <a:xfrm>
-            <a:off x="646733" y="4033689"/>
-            <a:ext cx="188268" cy="150614"/>
+            <a:off x="665560" y="4033689"/>
+            <a:ext cx="150614" cy="150614"/>
           </a:xfrm>
           <a:prstGeom prst="rect">
             <a:avLst/>
@@ -11481,8 +11481,8 @@
         </p:blipFill>
         <p:spPr>
           <a:xfrm>
-            <a:off x="637877" y="2988915"/>
-            <a:ext cx="177180" cy="141759"/>
+            <a:off x="655587" y="2988915"/>
+            <a:ext cx="141759" cy="141759"/>
           </a:xfrm>
           <a:prstGeom prst="rect">
             <a:avLst/>

</xml_diff>